<commit_message>
docs(deck): fix text overflow on the two Gateway slides
Three stat-card captions, the considerations band and the slide 2 title
all overran their boxes when measured with Arial metrics. Trimmed the
captions to one line each (the detail moved to the speaker notes), gave
the cards 0.08in more height, and shortened the slide 2 title so it stops
wrapping to two lines.
</commit_message>
<xml_diff>
--- a/docs/Valentin-Gateway-Slides.pptx
+++ b/docs/Valentin-Gateway-Slides.pptx
@@ -3775,7 +3775,7 @@
         <p:spPr>
           <a:xfrm>
             <a:off x="457200" y="1024128"/>
-            <a:ext cx="3593592" cy="1115568"/>
+            <a:ext cx="3593592" cy="1188720"/>
           </a:xfrm>
           <a:prstGeom prst="rect">
             <a:avLst/>
@@ -3898,7 +3898,7 @@
         <p:spPr>
           <a:xfrm>
             <a:off x="640080" y="1426464"/>
-            <a:ext cx="3227832" cy="585216"/>
+            <a:ext cx="3227832" cy="658368"/>
           </a:xfrm>
           <a:prstGeom prst="rect">
             <a:avLst/>
@@ -3937,24 +3937,6 @@
               </a:rPr>
               <a:t>src/server/integrations/</a:t>
             </a:r>
-            <a:r>
-              <a:rPr sz="1150" b="0">
-                <a:solidFill>
-                  <a:srgbClr val="16191F"/>
-                </a:solidFill>
-                <a:latin typeface="Calibri"/>
-              </a:rPr>
-              <a:t> — assembled by </a:t>
-            </a:r>
-            <a:r>
-              <a:rPr sz="1100" b="0">
-                <a:solidFill>
-                  <a:srgbClr val="1F77A8"/>
-                </a:solidFill>
-                <a:latin typeface="Consolas"/>
-              </a:rPr>
-              <a:t>buildToolRegistry()</a:t>
-            </a:r>
           </a:p>
         </p:txBody>
       </p:sp>
@@ -3967,7 +3949,7 @@
         <p:spPr>
           <a:xfrm>
             <a:off x="4297679" y="1024128"/>
-            <a:ext cx="3593592" cy="1115568"/>
+            <a:ext cx="3593592" cy="1188720"/>
           </a:xfrm>
           <a:prstGeom prst="rect">
             <a:avLst/>
@@ -4090,7 +4072,7 @@
         <p:spPr>
           <a:xfrm>
             <a:off x="4480559" y="1426464"/>
-            <a:ext cx="3227832" cy="585216"/>
+            <a:ext cx="3227832" cy="658368"/>
           </a:xfrm>
           <a:prstGeom prst="rect">
             <a:avLst/>
@@ -4138,15 +4120,6 @@
               </a:rPr>
               <a:t>propose_*</a:t>
             </a:r>
-            <a:r>
-              <a:rPr sz="1150" b="0">
-                <a:solidFill>
-                  <a:srgbClr val="16191F"/>
-                </a:solidFill>
-                <a:latin typeface="Calibri"/>
-              </a:rPr>
-              <a:t> that cannot act without a human</a:t>
-            </a:r>
           </a:p>
         </p:txBody>
       </p:sp>
@@ -4159,7 +4132,7 @@
         <p:spPr>
           <a:xfrm>
             <a:off x="8138160" y="1024128"/>
-            <a:ext cx="3593592" cy="1115568"/>
+            <a:ext cx="3593592" cy="1188720"/>
           </a:xfrm>
           <a:prstGeom prst="rect">
             <a:avLst/>
@@ -4282,7 +4255,7 @@
         <p:spPr>
           <a:xfrm>
             <a:off x="8321040" y="1426464"/>
-            <a:ext cx="3227832" cy="585216"/>
+            <a:ext cx="3227832" cy="658368"/>
           </a:xfrm>
           <a:prstGeom prst="rect">
             <a:avLst/>
@@ -4341,7 +4314,7 @@
         </p:nvSpPr>
         <p:spPr>
           <a:xfrm>
-            <a:off x="457200" y="2231136"/>
+            <a:off x="457200" y="2304288"/>
             <a:ext cx="11274552" cy="768096"/>
           </a:xfrm>
           <a:prstGeom prst="rect">
@@ -4385,7 +4358,7 @@
         </p:nvSpPr>
         <p:spPr>
           <a:xfrm>
-            <a:off x="658368" y="2331720"/>
+            <a:off x="658368" y="2404872"/>
             <a:ext cx="10872216" cy="219456"/>
           </a:xfrm>
           <a:prstGeom prst="rect">
@@ -4420,7 +4393,7 @@
         </p:nvSpPr>
         <p:spPr>
           <a:xfrm>
-            <a:off x="658368" y="2578608"/>
+            <a:off x="658368" y="2651760"/>
             <a:ext cx="10872216" cy="292607"/>
           </a:xfrm>
           <a:prstGeom prst="rect">
@@ -4491,7 +4464,7 @@
         </p:nvSpPr>
         <p:spPr>
           <a:xfrm>
-            <a:off x="457200" y="3127248"/>
+            <a:off x="457200" y="3182112"/>
             <a:ext cx="5513832" cy="1920240"/>
           </a:xfrm>
           <a:prstGeom prst="rect">
@@ -4535,7 +4508,7 @@
         </p:nvSpPr>
         <p:spPr>
           <a:xfrm>
-            <a:off x="457200" y="3127248"/>
+            <a:off x="457200" y="3182112"/>
             <a:ext cx="41148" cy="1920240"/>
           </a:xfrm>
           <a:prstGeom prst="rect">
@@ -4579,7 +4552,7 @@
         </p:nvSpPr>
         <p:spPr>
           <a:xfrm>
-            <a:off x="640080" y="3246120"/>
+            <a:off x="640080" y="3300984"/>
             <a:ext cx="5148072" cy="237744"/>
           </a:xfrm>
           <a:prstGeom prst="rect">
@@ -4623,7 +4596,7 @@
         </p:nvSpPr>
         <p:spPr>
           <a:xfrm>
-            <a:off x="640080" y="3529584"/>
+            <a:off x="640080" y="3584448"/>
             <a:ext cx="5148072" cy="1389888"/>
           </a:xfrm>
           <a:prstGeom prst="rect">
@@ -4817,7 +4790,7 @@
         </p:nvSpPr>
         <p:spPr>
           <a:xfrm>
-            <a:off x="6217920" y="3127248"/>
+            <a:off x="6217920" y="3182112"/>
             <a:ext cx="5513832" cy="1920240"/>
           </a:xfrm>
           <a:prstGeom prst="rect">
@@ -4861,7 +4834,7 @@
         </p:nvSpPr>
         <p:spPr>
           <a:xfrm>
-            <a:off x="6217920" y="3127248"/>
+            <a:off x="6217920" y="3182112"/>
             <a:ext cx="41148" cy="1920240"/>
           </a:xfrm>
           <a:prstGeom prst="rect">
@@ -4905,7 +4878,7 @@
         </p:nvSpPr>
         <p:spPr>
           <a:xfrm>
-            <a:off x="6400800" y="3246120"/>
+            <a:off x="6400800" y="3300984"/>
             <a:ext cx="5148072" cy="237744"/>
           </a:xfrm>
           <a:prstGeom prst="rect">
@@ -4949,7 +4922,7 @@
         </p:nvSpPr>
         <p:spPr>
           <a:xfrm>
-            <a:off x="6400800" y="3529584"/>
+            <a:off x="6400800" y="3584448"/>
             <a:ext cx="5148072" cy="1389888"/>
           </a:xfrm>
           <a:prstGeom prst="rect">
@@ -5125,8 +5098,8 @@
         </p:nvSpPr>
         <p:spPr>
           <a:xfrm>
-            <a:off x="457200" y="5175504"/>
-            <a:ext cx="11274552" cy="1060704"/>
+            <a:off x="457200" y="5212080"/>
+            <a:ext cx="11274552" cy="1115568"/>
           </a:xfrm>
           <a:prstGeom prst="rect">
             <a:avLst/>
@@ -5169,7 +5142,7 @@
         </p:nvSpPr>
         <p:spPr>
           <a:xfrm>
-            <a:off x="658368" y="5276088"/>
+            <a:off x="658368" y="5312664"/>
             <a:ext cx="10872216" cy="219456"/>
           </a:xfrm>
           <a:prstGeom prst="rect">
@@ -5204,8 +5177,8 @@
         </p:nvSpPr>
         <p:spPr>
           <a:xfrm>
-            <a:off x="658368" y="5522976"/>
-            <a:ext cx="10872216" cy="585215"/>
+            <a:off x="658368" y="5559552"/>
+            <a:ext cx="10872216" cy="640080"/>
           </a:xfrm>
           <a:prstGeom prst="rect">
             <a:avLst/>
@@ -5497,7 +5470,7 @@
                 </a:solidFill>
                 <a:latin typeface="Calibri"/>
               </a:rPr>
-              <a:t>What the AgentCore Gateway costs — </a:t>
+              <a:t>What AgentCore Gateway costs — </a:t>
             </a:r>
             <a:r>
               <a:rPr sz="2700" b="0">
@@ -5506,7 +5479,7 @@
                 </a:solidFill>
                 <a:latin typeface="Calibri"/>
               </a:rPr>
-              <a:t>two meters on unrelated clocks</a:t>
+              <a:t>two meters, not one price</a:t>
             </a:r>
           </a:p>
         </p:txBody>

</xml_diff>